<commit_message>
Presentation files (PPT and PDF)
</commit_message>
<xml_diff>
--- a/Pathfinder_Presentation.pptx
+++ b/Pathfinder_Presentation.pptx
@@ -131,17 +131,25 @@
 </p:presentation>
 </file>
 
+<file path=ppt/revisionInfo.xml><?xml version="1.0" encoding="utf-8"?>
+<p1510:revInfo xmlns:a="http://schemas.openxmlformats.org/drawingml/2006/main" xmlns:r="http://schemas.openxmlformats.org/officeDocument/2006/relationships" xmlns:p1510="http://schemas.microsoft.com/office/powerpoint/2015/10/main">
+  <p1510:revLst>
+    <p1510:client id="{FB3C03F5-2683-4A5F-8A34-CBFD62AA4020}" v="5" dt="2025-12-15T15:11:05.515"/>
+  </p1510:revLst>
+</p1510:revInfo>
+</file>
+
 <file path=ppt/changesInfos/changesInfo1.xml><?xml version="1.0" encoding="utf-8"?>
 <pc:chgInfo xmlns:a="http://schemas.openxmlformats.org/drawingml/2006/main" xmlns:r="http://schemas.openxmlformats.org/officeDocument/2006/relationships" xmlns:ac="http://schemas.microsoft.com/office/drawing/2013/main/command" xmlns:pc="http://schemas.microsoft.com/office/powerpoint/2013/main/command">
   <pc:docChgLst>
     <pc:chgData name="Rithvik Goud Mushkam" userId="cf6f2cd1d37e7575" providerId="LiveId" clId="{5D4E4D88-3F70-44ED-9AD7-40354431CA08}"/>
     <pc:docChg chg="custSel modSld">
-      <pc:chgData name="Rithvik Goud Mushkam" userId="cf6f2cd1d37e7575" providerId="LiveId" clId="{5D4E4D88-3F70-44ED-9AD7-40354431CA08}" dt="2025-12-04T12:55:39.163" v="73" actId="14100"/>
+      <pc:chgData name="Rithvik Goud Mushkam" userId="cf6f2cd1d37e7575" providerId="LiveId" clId="{5D4E4D88-3F70-44ED-9AD7-40354431CA08}" dt="2025-12-15T15:12:14.176" v="200" actId="1076"/>
       <pc:docMkLst>
         <pc:docMk/>
       </pc:docMkLst>
-      <pc:sldChg chg="modSp mod">
-        <pc:chgData name="Rithvik Goud Mushkam" userId="cf6f2cd1d37e7575" providerId="LiveId" clId="{5D4E4D88-3F70-44ED-9AD7-40354431CA08}" dt="2025-12-04T12:55:39.163" v="73" actId="14100"/>
+      <pc:sldChg chg="addSp modSp mod">
+        <pc:chgData name="Rithvik Goud Mushkam" userId="cf6f2cd1d37e7575" providerId="LiveId" clId="{5D4E4D88-3F70-44ED-9AD7-40354431CA08}" dt="2025-12-15T15:12:14.176" v="200" actId="1076"/>
         <pc:sldMkLst>
           <pc:docMk/>
           <pc:sldMk cId="0" sldId="256"/>
@@ -152,6 +160,22 @@
             <pc:docMk/>
             <pc:sldMk cId="0" sldId="256"/>
             <ac:spMk id="2" creationId="{00000000-0000-0000-0000-000000000000}"/>
+          </ac:spMkLst>
+        </pc:spChg>
+        <pc:spChg chg="add mod">
+          <ac:chgData name="Rithvik Goud Mushkam" userId="cf6f2cd1d37e7575" providerId="LiveId" clId="{5D4E4D88-3F70-44ED-9AD7-40354431CA08}" dt="2025-12-15T15:10:48.183" v="166" actId="113"/>
+          <ac:spMkLst>
+            <pc:docMk/>
+            <pc:sldMk cId="0" sldId="256"/>
+            <ac:spMk id="3" creationId="{CE762FCA-CB65-E529-0CB3-46DABF01470C}"/>
+          </ac:spMkLst>
+        </pc:spChg>
+        <pc:spChg chg="add mod">
+          <ac:chgData name="Rithvik Goud Mushkam" userId="cf6f2cd1d37e7575" providerId="LiveId" clId="{5D4E4D88-3F70-44ED-9AD7-40354431CA08}" dt="2025-12-15T15:12:14.176" v="200" actId="1076"/>
+          <ac:spMkLst>
+            <pc:docMk/>
+            <pc:sldMk cId="0" sldId="256"/>
+            <ac:spMk id="4" creationId="{DA3861D2-8230-4E64-F8C8-130575EFC864}"/>
           </ac:spMkLst>
         </pc:spChg>
       </pc:sldChg>
@@ -22091,7 +22115,7 @@
           <a:p>
             <a:fld id="{5BCAD085-E8A6-8845-BD4E-CB4CCA059FC4}" type="datetimeFigureOut">
               <a:rPr lang="en-US" smtClean="0"/>
-              <a:t>12/4/2025</a:t>
+              <a:t>12/15/2025</a:t>
             </a:fld>
             <a:endParaRPr lang="en-US"/>
           </a:p>
@@ -22259,7 +22283,7 @@
           <a:p>
             <a:fld id="{5BCAD085-E8A6-8845-BD4E-CB4CCA059FC4}" type="datetimeFigureOut">
               <a:rPr lang="en-US" smtClean="0"/>
-              <a:t>12/4/2025</a:t>
+              <a:t>12/15/2025</a:t>
             </a:fld>
             <a:endParaRPr lang="en-US"/>
           </a:p>
@@ -22437,7 +22461,7 @@
           <a:p>
             <a:fld id="{5BCAD085-E8A6-8845-BD4E-CB4CCA059FC4}" type="datetimeFigureOut">
               <a:rPr lang="en-US" smtClean="0"/>
-              <a:t>12/4/2025</a:t>
+              <a:t>12/15/2025</a:t>
             </a:fld>
             <a:endParaRPr lang="en-US"/>
           </a:p>
@@ -22605,7 +22629,7 @@
           <a:p>
             <a:fld id="{5BCAD085-E8A6-8845-BD4E-CB4CCA059FC4}" type="datetimeFigureOut">
               <a:rPr lang="en-US" smtClean="0"/>
-              <a:t>12/4/2025</a:t>
+              <a:t>12/15/2025</a:t>
             </a:fld>
             <a:endParaRPr lang="en-US"/>
           </a:p>
@@ -22850,7 +22874,7 @@
           <a:p>
             <a:fld id="{5BCAD085-E8A6-8845-BD4E-CB4CCA059FC4}" type="datetimeFigureOut">
               <a:rPr lang="en-US" smtClean="0"/>
-              <a:t>12/4/2025</a:t>
+              <a:t>12/15/2025</a:t>
             </a:fld>
             <a:endParaRPr lang="en-US"/>
           </a:p>
@@ -23135,7 +23159,7 @@
           <a:p>
             <a:fld id="{5BCAD085-E8A6-8845-BD4E-CB4CCA059FC4}" type="datetimeFigureOut">
               <a:rPr lang="en-US" smtClean="0"/>
-              <a:t>12/4/2025</a:t>
+              <a:t>12/15/2025</a:t>
             </a:fld>
             <a:endParaRPr lang="en-US"/>
           </a:p>
@@ -23554,7 +23578,7 @@
           <a:p>
             <a:fld id="{5BCAD085-E8A6-8845-BD4E-CB4CCA059FC4}" type="datetimeFigureOut">
               <a:rPr lang="en-US" smtClean="0"/>
-              <a:t>12/4/2025</a:t>
+              <a:t>12/15/2025</a:t>
             </a:fld>
             <a:endParaRPr lang="en-US"/>
           </a:p>
@@ -23671,7 +23695,7 @@
           <a:p>
             <a:fld id="{5BCAD085-E8A6-8845-BD4E-CB4CCA059FC4}" type="datetimeFigureOut">
               <a:rPr lang="en-US" smtClean="0"/>
-              <a:t>12/4/2025</a:t>
+              <a:t>12/15/2025</a:t>
             </a:fld>
             <a:endParaRPr lang="en-US"/>
           </a:p>
@@ -23766,7 +23790,7 @@
           <a:p>
             <a:fld id="{5BCAD085-E8A6-8845-BD4E-CB4CCA059FC4}" type="datetimeFigureOut">
               <a:rPr lang="en-US" smtClean="0"/>
-              <a:t>12/4/2025</a:t>
+              <a:t>12/15/2025</a:t>
             </a:fld>
             <a:endParaRPr lang="en-US"/>
           </a:p>
@@ -24041,7 +24065,7 @@
           <a:p>
             <a:fld id="{5BCAD085-E8A6-8845-BD4E-CB4CCA059FC4}" type="datetimeFigureOut">
               <a:rPr lang="en-US" smtClean="0"/>
-              <a:t>12/4/2025</a:t>
+              <a:t>12/15/2025</a:t>
             </a:fld>
             <a:endParaRPr lang="en-US"/>
           </a:p>
@@ -24293,7 +24317,7 @@
           <a:p>
             <a:fld id="{5BCAD085-E8A6-8845-BD4E-CB4CCA059FC4}" type="datetimeFigureOut">
               <a:rPr lang="en-US" smtClean="0"/>
-              <a:t>12/4/2025</a:t>
+              <a:t>12/15/2025</a:t>
             </a:fld>
             <a:endParaRPr lang="en-US"/>
           </a:p>
@@ -24504,7 +24528,7 @@
           <a:p>
             <a:fld id="{5BCAD085-E8A6-8845-BD4E-CB4CCA059FC4}" type="datetimeFigureOut">
               <a:rPr lang="en-US" smtClean="0"/>
-              <a:t>12/4/2025</a:t>
+              <a:t>12/15/2025</a:t>
             </a:fld>
             <a:endParaRPr lang="en-US"/>
           </a:p>
@@ -25087,6 +25111,135 @@
           </a:fontRef>
         </p:style>
       </p:cxnSp>
+      <p:sp>
+        <p:nvSpPr>
+          <p:cNvPr id="3" name="TextBox 2">
+            <a:extLst>
+              <a:ext uri="{FF2B5EF4-FFF2-40B4-BE49-F238E27FC236}">
+                <a16:creationId xmlns:a16="http://schemas.microsoft.com/office/drawing/2014/main" id="{CE762FCA-CB65-E529-0CB3-46DABF01470C}"/>
+              </a:ext>
+            </a:extLst>
+          </p:cNvPr>
+          <p:cNvSpPr txBox="1"/>
+          <p:nvPr/>
+        </p:nvSpPr>
+        <p:spPr>
+          <a:xfrm>
+            <a:off x="5751871" y="4876800"/>
+            <a:ext cx="3146323" cy="1631216"/>
+          </a:xfrm>
+          <a:prstGeom prst="rect">
+            <a:avLst/>
+          </a:prstGeom>
+          <a:noFill/>
+        </p:spPr>
+        <p:txBody>
+          <a:bodyPr wrap="square" rtlCol="0">
+            <a:spAutoFit/>
+          </a:bodyPr>
+          <a:lstStyle/>
+          <a:p>
+            <a:r>
+              <a:rPr lang="en-US" sz="2000" b="1" dirty="0">
+                <a:latin typeface="Times New Roman" panose="02020603050405020304" pitchFamily="18" charset="0"/>
+                <a:cs typeface="Times New Roman" panose="02020603050405020304" pitchFamily="18" charset="0"/>
+              </a:rPr>
+              <a:t>Team-D</a:t>
+            </a:r>
+          </a:p>
+          <a:p>
+            <a:r>
+              <a:rPr lang="en-US" sz="2000" dirty="0">
+                <a:latin typeface="Times New Roman" panose="02020603050405020304" pitchFamily="18" charset="0"/>
+                <a:cs typeface="Times New Roman" panose="02020603050405020304" pitchFamily="18" charset="0"/>
+              </a:rPr>
+              <a:t>Rithvik Goud Mushkam</a:t>
+            </a:r>
+          </a:p>
+          <a:p>
+            <a:r>
+              <a:rPr lang="en-US" sz="2000" dirty="0">
+                <a:latin typeface="Times New Roman" panose="02020603050405020304" pitchFamily="18" charset="0"/>
+                <a:cs typeface="Times New Roman" panose="02020603050405020304" pitchFamily="18" charset="0"/>
+              </a:rPr>
+              <a:t>Saransh Thakran</a:t>
+            </a:r>
+          </a:p>
+          <a:p>
+            <a:r>
+              <a:rPr lang="en-US" sz="2000" dirty="0">
+                <a:latin typeface="Times New Roman" panose="02020603050405020304" pitchFamily="18" charset="0"/>
+                <a:cs typeface="Times New Roman" panose="02020603050405020304" pitchFamily="18" charset="0"/>
+              </a:rPr>
+              <a:t>Subhasree </a:t>
+            </a:r>
+            <a:r>
+              <a:rPr lang="en-US" sz="2000" dirty="0" err="1">
+                <a:latin typeface="Times New Roman" panose="02020603050405020304" pitchFamily="18" charset="0"/>
+                <a:cs typeface="Times New Roman" panose="02020603050405020304" pitchFamily="18" charset="0"/>
+              </a:rPr>
+              <a:t>Yenigalla</a:t>
+            </a:r>
+            <a:endParaRPr lang="en-US" sz="2000" dirty="0">
+              <a:latin typeface="Times New Roman" panose="02020603050405020304" pitchFamily="18" charset="0"/>
+              <a:cs typeface="Times New Roman" panose="02020603050405020304" pitchFamily="18" charset="0"/>
+            </a:endParaRPr>
+          </a:p>
+          <a:p>
+            <a:r>
+              <a:rPr lang="en-US" sz="2000" dirty="0">
+                <a:latin typeface="Times New Roman" panose="02020603050405020304" pitchFamily="18" charset="0"/>
+                <a:cs typeface="Times New Roman" panose="02020603050405020304" pitchFamily="18" charset="0"/>
+              </a:rPr>
+              <a:t>B Sahithya Varma</a:t>
+            </a:r>
+            <a:endParaRPr lang="en-IN" sz="2000" dirty="0">
+              <a:latin typeface="Times New Roman" panose="02020603050405020304" pitchFamily="18" charset="0"/>
+              <a:cs typeface="Times New Roman" panose="02020603050405020304" pitchFamily="18" charset="0"/>
+            </a:endParaRPr>
+          </a:p>
+        </p:txBody>
+      </p:sp>
+      <p:sp>
+        <p:nvSpPr>
+          <p:cNvPr id="4" name="TextBox 3">
+            <a:extLst>
+              <a:ext uri="{FF2B5EF4-FFF2-40B4-BE49-F238E27FC236}">
+                <a16:creationId xmlns:a16="http://schemas.microsoft.com/office/drawing/2014/main" id="{DA3861D2-8230-4E64-F8C8-130575EFC864}"/>
+              </a:ext>
+            </a:extLst>
+          </p:cNvPr>
+          <p:cNvSpPr txBox="1"/>
+          <p:nvPr/>
+        </p:nvSpPr>
+        <p:spPr>
+          <a:xfrm>
+            <a:off x="245806" y="6044693"/>
+            <a:ext cx="3274142" cy="369332"/>
+          </a:xfrm>
+          <a:prstGeom prst="rect">
+            <a:avLst/>
+          </a:prstGeom>
+          <a:noFill/>
+        </p:spPr>
+        <p:txBody>
+          <a:bodyPr wrap="square" rtlCol="0">
+            <a:spAutoFit/>
+          </a:bodyPr>
+          <a:lstStyle/>
+          <a:p>
+            <a:r>
+              <a:rPr lang="en-US" b="1" dirty="0"/>
+              <a:t>Mentor:</a:t>
+            </a:r>
+            <a:r>
+              <a:rPr lang="en-US" dirty="0"/>
+              <a:t> Sangeetha Mahalingam</a:t>
+            </a:r>
+            <a:endParaRPr lang="en-IN" dirty="0"/>
+          </a:p>
+        </p:txBody>
+      </p:sp>
     </p:spTree>
   </p:cSld>
   <p:clrMapOvr>

</xml_diff>